<commit_message>
Add live app link to README and presentation
Co-Authored-By: Claude Opus 4.8 <noreply@anthropic.com>
</commit_message>
<xml_diff>
--- a/1.Capstone_DigitalAssetAssistant/Deliverables/Step6_DigitalAsset_Presentation.pptx
+++ b/1.Capstone_DigitalAssetAssistant/Deliverables/Step6_DigitalAsset_Presentation.pptx
@@ -3287,6 +3287,42 @@
                 <a:latin typeface="Calibri"/>
               </a:rPr>
               <a:t>AI PM Capstone 2   |   Ushasree Jakilinki</a:t>
+            </a:r>
+          </a:p>
+        </p:txBody>
+      </p:sp>
+      <p:sp>
+        <p:nvSpPr>
+          <p:cNvPr id="6" name="TextBox 5"/>
+          <p:cNvSpPr txBox="1"/>
+          <p:nvPr/>
+        </p:nvSpPr>
+        <p:spPr>
+          <a:xfrm>
+            <a:off x="822960" y="4206240"/>
+            <a:ext cx="10515600" cy="548640"/>
+          </a:xfrm>
+          <a:prstGeom prst="rect">
+            <a:avLst/>
+          </a:prstGeom>
+          <a:noFill/>
+        </p:spPr>
+        <p:txBody>
+          <a:bodyPr wrap="square">
+            <a:spAutoFit/>
+          </a:bodyPr>
+          <a:lstStyle/>
+          <a:p>
+            <a:pPr algn="l"/>
+            <a:r>
+              <a:rPr sz="1800" b="1">
+                <a:solidFill>
+                  <a:srgbClr val="02C39A"/>
+                </a:solidFill>
+                <a:latin typeface="Calibri"/>
+                <a:hlinkClick r:id="rId2"/>
+              </a:rPr>
+              <a:t>▶ Try the live app:  https://codebasicsaipm-capstonedigitalassistant.streamlit.app/</a:t>
             </a:r>
           </a:p>
         </p:txBody>

</xml_diff>